<commit_message>
Update final documentation and presentation
</commit_message>
<xml_diff>
--- a/presentation/Project_Presentation.pptx
+++ b/presentation/Project_Presentation.pptx
@@ -5,18 +5,18 @@
     <p:sldMasterId id="2147483648" r:id="rId1"/>
   </p:sldMasterIdLst>
   <p:sldIdLst>
-    <p:sldId id="256" r:id="rId7"/>
-    <p:sldId id="257" r:id="rId8"/>
-    <p:sldId id="258" r:id="rId9"/>
-    <p:sldId id="259" r:id="rId10"/>
-    <p:sldId id="260" r:id="rId11"/>
-    <p:sldId id="261" r:id="rId12"/>
-    <p:sldId id="262" r:id="rId13"/>
-    <p:sldId id="263" r:id="rId14"/>
-    <p:sldId id="264" r:id="rId15"/>
-    <p:sldId id="265" r:id="rId16"/>
+    <p:sldId id="256" r:id="rId2"/>
+    <p:sldId id="257" r:id="rId3"/>
+    <p:sldId id="258" r:id="rId4"/>
+    <p:sldId id="259" r:id="rId5"/>
+    <p:sldId id="260" r:id="rId6"/>
+    <p:sldId id="261" r:id="rId7"/>
+    <p:sldId id="262" r:id="rId8"/>
+    <p:sldId id="263" r:id="rId9"/>
+    <p:sldId id="264" r:id="rId10"/>
+    <p:sldId id="265" r:id="rId11"/>
   </p:sldIdLst>
-  <p:sldSz cx="12191695" cy="6858000" type="screen4x3"/>
+  <p:sldSz cx="12192000" cy="6858000"/>
   <p:notesSz cx="6858000" cy="9144000"/>
   <p:defaultTextStyle>
     <a:defPPr>
@@ -113,6 +113,22 @@
       </a:defRPr>
     </a:lvl9pPr>
   </p:defaultTextStyle>
+  <p:extLst>
+    <p:ext uri="{EFAFB233-063F-42B5-8137-9DF3F51BA10A}">
+      <p15:sldGuideLst xmlns:p15="http://schemas.microsoft.com/office/powerpoint/2012/main">
+        <p15:guide id="1" orient="horz" pos="2160">
+          <p15:clr>
+            <a:srgbClr val="A4A3A4"/>
+          </p15:clr>
+        </p15:guide>
+        <p15:guide id="2" pos="2880">
+          <p15:clr>
+            <a:srgbClr val="A4A3A4"/>
+          </p15:clr>
+        </p15:guide>
+      </p15:sldGuideLst>
+    </p:ext>
+  </p:extLst>
 </p:presentation>
 </file>
 
@@ -154,10 +170,9 @@
           <a:lstStyle/>
           <a:p>
             <a:r>
-              <a:rPr lang="en-US" smtClean="0"/>
+              <a:rPr lang="en-US"/>
               <a:t>Click to edit Master title style</a:t>
             </a:r>
-            <a:endParaRPr lang="en-US"/>
           </a:p>
         </p:txBody>
       </p:sp>
@@ -273,10 +288,9 @@
           </a:lstStyle>
           <a:p>
             <a:r>
-              <a:rPr lang="en-US" smtClean="0"/>
+              <a:rPr lang="en-US"/>
               <a:t>Click to edit Master subtitle style</a:t>
             </a:r>
-            <a:endParaRPr lang="en-US"/>
           </a:p>
         </p:txBody>
       </p:sp>
@@ -297,7 +311,7 @@
           <a:p>
             <a:fld id="{5BCAD085-E8A6-8845-BD4E-CB4CCA059FC4}" type="datetimeFigureOut">
               <a:rPr lang="en-US" smtClean="0"/>
-              <a:t>1/27/13</a:t>
+              <a:t>10/29/2026</a:t>
             </a:fld>
             <a:endParaRPr lang="en-US"/>
           </a:p>
@@ -391,10 +405,9 @@
           <a:lstStyle/>
           <a:p>
             <a:r>
-              <a:rPr lang="en-US" smtClean="0"/>
+              <a:rPr lang="en-US"/>
               <a:t>Click to edit Master title style</a:t>
             </a:r>
-            <a:endParaRPr lang="en-US"/>
           </a:p>
         </p:txBody>
       </p:sp>
@@ -415,38 +428,37 @@
           <a:p>
             <a:pPr lvl="0"/>
             <a:r>
-              <a:rPr lang="en-US" smtClean="0"/>
+              <a:rPr lang="en-US"/>
               <a:t>Click to edit Master text styles</a:t>
             </a:r>
           </a:p>
           <a:p>
             <a:pPr lvl="1"/>
             <a:r>
-              <a:rPr lang="en-US" smtClean="0"/>
+              <a:rPr lang="en-US"/>
               <a:t>Second level</a:t>
             </a:r>
           </a:p>
           <a:p>
             <a:pPr lvl="2"/>
             <a:r>
-              <a:rPr lang="en-US" smtClean="0"/>
+              <a:rPr lang="en-US"/>
               <a:t>Third level</a:t>
             </a:r>
           </a:p>
           <a:p>
             <a:pPr lvl="3"/>
             <a:r>
-              <a:rPr lang="en-US" smtClean="0"/>
+              <a:rPr lang="en-US"/>
               <a:t>Fourth level</a:t>
             </a:r>
           </a:p>
           <a:p>
             <a:pPr lvl="4"/>
             <a:r>
-              <a:rPr lang="en-US" smtClean="0"/>
+              <a:rPr lang="en-US"/>
               <a:t>Fifth level</a:t>
             </a:r>
-            <a:endParaRPr lang="en-US"/>
           </a:p>
         </p:txBody>
       </p:sp>
@@ -467,7 +479,7 @@
           <a:p>
             <a:fld id="{5BCAD085-E8A6-8845-BD4E-CB4CCA059FC4}" type="datetimeFigureOut">
               <a:rPr lang="en-US" smtClean="0"/>
-              <a:t>1/27/13</a:t>
+              <a:t>10/29/2026</a:t>
             </a:fld>
             <a:endParaRPr lang="en-US"/>
           </a:p>
@@ -566,10 +578,9 @@
           <a:lstStyle/>
           <a:p>
             <a:r>
-              <a:rPr lang="en-US" smtClean="0"/>
+              <a:rPr lang="en-US"/>
               <a:t>Click to edit Master title style</a:t>
             </a:r>
-            <a:endParaRPr lang="en-US"/>
           </a:p>
         </p:txBody>
       </p:sp>
@@ -595,38 +606,37 @@
           <a:p>
             <a:pPr lvl="0"/>
             <a:r>
-              <a:rPr lang="en-US" smtClean="0"/>
+              <a:rPr lang="en-US"/>
               <a:t>Click to edit Master text styles</a:t>
             </a:r>
           </a:p>
           <a:p>
             <a:pPr lvl="1"/>
             <a:r>
-              <a:rPr lang="en-US" smtClean="0"/>
+              <a:rPr lang="en-US"/>
               <a:t>Second level</a:t>
             </a:r>
           </a:p>
           <a:p>
             <a:pPr lvl="2"/>
             <a:r>
-              <a:rPr lang="en-US" smtClean="0"/>
+              <a:rPr lang="en-US"/>
               <a:t>Third level</a:t>
             </a:r>
           </a:p>
           <a:p>
             <a:pPr lvl="3"/>
             <a:r>
-              <a:rPr lang="en-US" smtClean="0"/>
+              <a:rPr lang="en-US"/>
               <a:t>Fourth level</a:t>
             </a:r>
           </a:p>
           <a:p>
             <a:pPr lvl="4"/>
             <a:r>
-              <a:rPr lang="en-US" smtClean="0"/>
+              <a:rPr lang="en-US"/>
               <a:t>Fifth level</a:t>
             </a:r>
-            <a:endParaRPr lang="en-US"/>
           </a:p>
         </p:txBody>
       </p:sp>
@@ -647,7 +657,7 @@
           <a:p>
             <a:fld id="{5BCAD085-E8A6-8845-BD4E-CB4CCA059FC4}" type="datetimeFigureOut">
               <a:rPr lang="en-US" smtClean="0"/>
-              <a:t>1/27/13</a:t>
+              <a:t>10/29/2026</a:t>
             </a:fld>
             <a:endParaRPr lang="en-US"/>
           </a:p>
@@ -741,10 +751,9 @@
           <a:lstStyle/>
           <a:p>
             <a:r>
-              <a:rPr lang="en-US" smtClean="0"/>
+              <a:rPr lang="en-US"/>
               <a:t>Click to edit Master title style</a:t>
             </a:r>
-            <a:endParaRPr lang="en-US"/>
           </a:p>
         </p:txBody>
       </p:sp>
@@ -765,38 +774,37 @@
           <a:p>
             <a:pPr lvl="0"/>
             <a:r>
-              <a:rPr lang="en-US" smtClean="0"/>
+              <a:rPr lang="en-US"/>
               <a:t>Click to edit Master text styles</a:t>
             </a:r>
           </a:p>
           <a:p>
             <a:pPr lvl="1"/>
             <a:r>
-              <a:rPr lang="en-US" smtClean="0"/>
+              <a:rPr lang="en-US"/>
               <a:t>Second level</a:t>
             </a:r>
           </a:p>
           <a:p>
             <a:pPr lvl="2"/>
             <a:r>
-              <a:rPr lang="en-US" smtClean="0"/>
+              <a:rPr lang="en-US"/>
               <a:t>Third level</a:t>
             </a:r>
           </a:p>
           <a:p>
             <a:pPr lvl="3"/>
             <a:r>
-              <a:rPr lang="en-US" smtClean="0"/>
+              <a:rPr lang="en-US"/>
               <a:t>Fourth level</a:t>
             </a:r>
           </a:p>
           <a:p>
             <a:pPr lvl="4"/>
             <a:r>
-              <a:rPr lang="en-US" smtClean="0"/>
+              <a:rPr lang="en-US"/>
               <a:t>Fifth level</a:t>
             </a:r>
-            <a:endParaRPr lang="en-US"/>
           </a:p>
         </p:txBody>
       </p:sp>
@@ -817,7 +825,7 @@
           <a:p>
             <a:fld id="{5BCAD085-E8A6-8845-BD4E-CB4CCA059FC4}" type="datetimeFigureOut">
               <a:rPr lang="en-US" smtClean="0"/>
-              <a:t>1/27/13</a:t>
+              <a:t>10/29/2026</a:t>
             </a:fld>
             <a:endParaRPr lang="en-US"/>
           </a:p>
@@ -920,10 +928,9 @@
           </a:lstStyle>
           <a:p>
             <a:r>
-              <a:rPr lang="en-US" smtClean="0"/>
+              <a:rPr lang="en-US"/>
               <a:t>Click to edit Master title style</a:t>
             </a:r>
-            <a:endParaRPr lang="en-US"/>
           </a:p>
         </p:txBody>
       </p:sp>
@@ -1040,7 +1047,7 @@
           <a:p>
             <a:pPr lvl="0"/>
             <a:r>
-              <a:rPr lang="en-US" smtClean="0"/>
+              <a:rPr lang="en-US"/>
               <a:t>Click to edit Master text styles</a:t>
             </a:r>
           </a:p>
@@ -1063,7 +1070,7 @@
           <a:p>
             <a:fld id="{5BCAD085-E8A6-8845-BD4E-CB4CCA059FC4}" type="datetimeFigureOut">
               <a:rPr lang="en-US" smtClean="0"/>
-              <a:t>1/27/13</a:t>
+              <a:t>10/29/2026</a:t>
             </a:fld>
             <a:endParaRPr lang="en-US"/>
           </a:p>
@@ -1157,10 +1164,9 @@
           <a:lstStyle/>
           <a:p>
             <a:r>
-              <a:rPr lang="en-US" smtClean="0"/>
+              <a:rPr lang="en-US"/>
               <a:t>Click to edit Master title style</a:t>
             </a:r>
-            <a:endParaRPr lang="en-US"/>
           </a:p>
         </p:txBody>
       </p:sp>
@@ -1214,38 +1220,37 @@
           <a:p>
             <a:pPr lvl="0"/>
             <a:r>
-              <a:rPr lang="en-US" smtClean="0"/>
+              <a:rPr lang="en-US"/>
               <a:t>Click to edit Master text styles</a:t>
             </a:r>
           </a:p>
           <a:p>
             <a:pPr lvl="1"/>
             <a:r>
-              <a:rPr lang="en-US" smtClean="0"/>
+              <a:rPr lang="en-US"/>
               <a:t>Second level</a:t>
             </a:r>
           </a:p>
           <a:p>
             <a:pPr lvl="2"/>
             <a:r>
-              <a:rPr lang="en-US" smtClean="0"/>
+              <a:rPr lang="en-US"/>
               <a:t>Third level</a:t>
             </a:r>
           </a:p>
           <a:p>
             <a:pPr lvl="3"/>
             <a:r>
-              <a:rPr lang="en-US" smtClean="0"/>
+              <a:rPr lang="en-US"/>
               <a:t>Fourth level</a:t>
             </a:r>
           </a:p>
           <a:p>
             <a:pPr lvl="4"/>
             <a:r>
-              <a:rPr lang="en-US" smtClean="0"/>
+              <a:rPr lang="en-US"/>
               <a:t>Fifth level</a:t>
             </a:r>
-            <a:endParaRPr lang="en-US"/>
           </a:p>
         </p:txBody>
       </p:sp>
@@ -1299,38 +1304,37 @@
           <a:p>
             <a:pPr lvl="0"/>
             <a:r>
-              <a:rPr lang="en-US" smtClean="0"/>
+              <a:rPr lang="en-US"/>
               <a:t>Click to edit Master text styles</a:t>
             </a:r>
           </a:p>
           <a:p>
             <a:pPr lvl="1"/>
             <a:r>
-              <a:rPr lang="en-US" smtClean="0"/>
+              <a:rPr lang="en-US"/>
               <a:t>Second level</a:t>
             </a:r>
           </a:p>
           <a:p>
             <a:pPr lvl="2"/>
             <a:r>
-              <a:rPr lang="en-US" smtClean="0"/>
+              <a:rPr lang="en-US"/>
               <a:t>Third level</a:t>
             </a:r>
           </a:p>
           <a:p>
             <a:pPr lvl="3"/>
             <a:r>
-              <a:rPr lang="en-US" smtClean="0"/>
+              <a:rPr lang="en-US"/>
               <a:t>Fourth level</a:t>
             </a:r>
           </a:p>
           <a:p>
             <a:pPr lvl="4"/>
             <a:r>
-              <a:rPr lang="en-US" smtClean="0"/>
+              <a:rPr lang="en-US"/>
               <a:t>Fifth level</a:t>
             </a:r>
-            <a:endParaRPr lang="en-US"/>
           </a:p>
         </p:txBody>
       </p:sp>
@@ -1351,7 +1355,7 @@
           <a:p>
             <a:fld id="{5BCAD085-E8A6-8845-BD4E-CB4CCA059FC4}" type="datetimeFigureOut">
               <a:rPr lang="en-US" smtClean="0"/>
-              <a:t>1/27/13</a:t>
+              <a:t>10/29/2026</a:t>
             </a:fld>
             <a:endParaRPr lang="en-US"/>
           </a:p>
@@ -1449,10 +1453,9 @@
           </a:lstStyle>
           <a:p>
             <a:r>
-              <a:rPr lang="en-US" smtClean="0"/>
+              <a:rPr lang="en-US"/>
               <a:t>Click to edit Master title style</a:t>
             </a:r>
-            <a:endParaRPr lang="en-US"/>
           </a:p>
         </p:txBody>
       </p:sp>
@@ -1515,7 +1518,7 @@
           <a:p>
             <a:pPr lvl="0"/>
             <a:r>
-              <a:rPr lang="en-US" smtClean="0"/>
+              <a:rPr lang="en-US"/>
               <a:t>Click to edit Master text styles</a:t>
             </a:r>
           </a:p>
@@ -1571,38 +1574,37 @@
           <a:p>
             <a:pPr lvl="0"/>
             <a:r>
-              <a:rPr lang="en-US" smtClean="0"/>
+              <a:rPr lang="en-US"/>
               <a:t>Click to edit Master text styles</a:t>
             </a:r>
           </a:p>
           <a:p>
             <a:pPr lvl="1"/>
             <a:r>
-              <a:rPr lang="en-US" smtClean="0"/>
+              <a:rPr lang="en-US"/>
               <a:t>Second level</a:t>
             </a:r>
           </a:p>
           <a:p>
             <a:pPr lvl="2"/>
             <a:r>
-              <a:rPr lang="en-US" smtClean="0"/>
+              <a:rPr lang="en-US"/>
               <a:t>Third level</a:t>
             </a:r>
           </a:p>
           <a:p>
             <a:pPr lvl="3"/>
             <a:r>
-              <a:rPr lang="en-US" smtClean="0"/>
+              <a:rPr lang="en-US"/>
               <a:t>Fourth level</a:t>
             </a:r>
           </a:p>
           <a:p>
             <a:pPr lvl="4"/>
             <a:r>
-              <a:rPr lang="en-US" smtClean="0"/>
+              <a:rPr lang="en-US"/>
               <a:t>Fifth level</a:t>
             </a:r>
-            <a:endParaRPr lang="en-US"/>
           </a:p>
         </p:txBody>
       </p:sp>
@@ -1665,7 +1667,7 @@
           <a:p>
             <a:pPr lvl="0"/>
             <a:r>
-              <a:rPr lang="en-US" smtClean="0"/>
+              <a:rPr lang="en-US"/>
               <a:t>Click to edit Master text styles</a:t>
             </a:r>
           </a:p>
@@ -1721,38 +1723,37 @@
           <a:p>
             <a:pPr lvl="0"/>
             <a:r>
-              <a:rPr lang="en-US" smtClean="0"/>
+              <a:rPr lang="en-US"/>
               <a:t>Click to edit Master text styles</a:t>
             </a:r>
           </a:p>
           <a:p>
             <a:pPr lvl="1"/>
             <a:r>
-              <a:rPr lang="en-US" smtClean="0"/>
+              <a:rPr lang="en-US"/>
               <a:t>Second level</a:t>
             </a:r>
           </a:p>
           <a:p>
             <a:pPr lvl="2"/>
             <a:r>
-              <a:rPr lang="en-US" smtClean="0"/>
+              <a:rPr lang="en-US"/>
               <a:t>Third level</a:t>
             </a:r>
           </a:p>
           <a:p>
             <a:pPr lvl="3"/>
             <a:r>
-              <a:rPr lang="en-US" smtClean="0"/>
+              <a:rPr lang="en-US"/>
               <a:t>Fourth level</a:t>
             </a:r>
           </a:p>
           <a:p>
             <a:pPr lvl="4"/>
             <a:r>
-              <a:rPr lang="en-US" smtClean="0"/>
+              <a:rPr lang="en-US"/>
               <a:t>Fifth level</a:t>
             </a:r>
-            <a:endParaRPr lang="en-US"/>
           </a:p>
         </p:txBody>
       </p:sp>
@@ -1773,7 +1774,7 @@
           <a:p>
             <a:fld id="{5BCAD085-E8A6-8845-BD4E-CB4CCA059FC4}" type="datetimeFigureOut">
               <a:rPr lang="en-US" smtClean="0"/>
-              <a:t>1/27/13</a:t>
+              <a:t>10/29/2026</a:t>
             </a:fld>
             <a:endParaRPr lang="en-US"/>
           </a:p>
@@ -1867,10 +1868,9 @@
           <a:lstStyle/>
           <a:p>
             <a:r>
-              <a:rPr lang="en-US" smtClean="0"/>
+              <a:rPr lang="en-US"/>
               <a:t>Click to edit Master title style</a:t>
             </a:r>
-            <a:endParaRPr lang="en-US"/>
           </a:p>
         </p:txBody>
       </p:sp>
@@ -1891,7 +1891,7 @@
           <a:p>
             <a:fld id="{5BCAD085-E8A6-8845-BD4E-CB4CCA059FC4}" type="datetimeFigureOut">
               <a:rPr lang="en-US" smtClean="0"/>
-              <a:t>1/27/13</a:t>
+              <a:t>10/29/2026</a:t>
             </a:fld>
             <a:endParaRPr lang="en-US"/>
           </a:p>
@@ -1986,7 +1986,7 @@
           <a:p>
             <a:fld id="{5BCAD085-E8A6-8845-BD4E-CB4CCA059FC4}" type="datetimeFigureOut">
               <a:rPr lang="en-US" smtClean="0"/>
-              <a:t>1/27/13</a:t>
+              <a:t>10/29/2026</a:t>
             </a:fld>
             <a:endParaRPr lang="en-US"/>
           </a:p>
@@ -2089,10 +2089,9 @@
           </a:lstStyle>
           <a:p>
             <a:r>
-              <a:rPr lang="en-US" smtClean="0"/>
+              <a:rPr lang="en-US"/>
               <a:t>Click to edit Master title style</a:t>
             </a:r>
-            <a:endParaRPr lang="en-US"/>
           </a:p>
         </p:txBody>
       </p:sp>
@@ -2146,38 +2145,37 @@
           <a:p>
             <a:pPr lvl="0"/>
             <a:r>
-              <a:rPr lang="en-US" smtClean="0"/>
+              <a:rPr lang="en-US"/>
               <a:t>Click to edit Master text styles</a:t>
             </a:r>
           </a:p>
           <a:p>
             <a:pPr lvl="1"/>
             <a:r>
-              <a:rPr lang="en-US" smtClean="0"/>
+              <a:rPr lang="en-US"/>
               <a:t>Second level</a:t>
             </a:r>
           </a:p>
           <a:p>
             <a:pPr lvl="2"/>
             <a:r>
-              <a:rPr lang="en-US" smtClean="0"/>
+              <a:rPr lang="en-US"/>
               <a:t>Third level</a:t>
             </a:r>
           </a:p>
           <a:p>
             <a:pPr lvl="3"/>
             <a:r>
-              <a:rPr lang="en-US" smtClean="0"/>
+              <a:rPr lang="en-US"/>
               <a:t>Fourth level</a:t>
             </a:r>
           </a:p>
           <a:p>
             <a:pPr lvl="4"/>
             <a:r>
-              <a:rPr lang="en-US" smtClean="0"/>
+              <a:rPr lang="en-US"/>
               <a:t>Fifth level</a:t>
             </a:r>
-            <a:endParaRPr lang="en-US"/>
           </a:p>
         </p:txBody>
       </p:sp>
@@ -2240,7 +2238,7 @@
           <a:p>
             <a:pPr lvl="0"/>
             <a:r>
-              <a:rPr lang="en-US" smtClean="0"/>
+              <a:rPr lang="en-US"/>
               <a:t>Click to edit Master text styles</a:t>
             </a:r>
           </a:p>
@@ -2263,7 +2261,7 @@
           <a:p>
             <a:fld id="{5BCAD085-E8A6-8845-BD4E-CB4CCA059FC4}" type="datetimeFigureOut">
               <a:rPr lang="en-US" smtClean="0"/>
-              <a:t>1/27/13</a:t>
+              <a:t>10/29/2026</a:t>
             </a:fld>
             <a:endParaRPr lang="en-US"/>
           </a:p>
@@ -2366,10 +2364,9 @@
           </a:lstStyle>
           <a:p>
             <a:r>
-              <a:rPr lang="en-US" smtClean="0"/>
+              <a:rPr lang="en-US"/>
               <a:t>Click to edit Master title style</a:t>
             </a:r>
-            <a:endParaRPr lang="en-US"/>
           </a:p>
         </p:txBody>
       </p:sp>
@@ -2493,7 +2490,7 @@
           <a:p>
             <a:pPr lvl="0"/>
             <a:r>
-              <a:rPr lang="en-US" smtClean="0"/>
+              <a:rPr lang="en-US"/>
               <a:t>Click to edit Master text styles</a:t>
             </a:r>
           </a:p>
@@ -2516,7 +2513,7 @@
           <a:p>
             <a:fld id="{5BCAD085-E8A6-8845-BD4E-CB4CCA059FC4}" type="datetimeFigureOut">
               <a:rPr lang="en-US" smtClean="0"/>
-              <a:t>1/27/13</a:t>
+              <a:t>10/29/2026</a:t>
             </a:fld>
             <a:endParaRPr lang="en-US"/>
           </a:p>
@@ -2625,10 +2622,9 @@
           <a:lstStyle/>
           <a:p>
             <a:r>
-              <a:rPr lang="en-US" smtClean="0"/>
+              <a:rPr lang="en-US"/>
               <a:t>Click to edit Master title style</a:t>
             </a:r>
-            <a:endParaRPr lang="en-US"/>
           </a:p>
         </p:txBody>
       </p:sp>
@@ -2659,38 +2655,37 @@
           <a:p>
             <a:pPr lvl="0"/>
             <a:r>
-              <a:rPr lang="en-US" smtClean="0"/>
+              <a:rPr lang="en-US"/>
               <a:t>Click to edit Master text styles</a:t>
             </a:r>
           </a:p>
           <a:p>
             <a:pPr lvl="1"/>
             <a:r>
-              <a:rPr lang="en-US" smtClean="0"/>
+              <a:rPr lang="en-US"/>
               <a:t>Second level</a:t>
             </a:r>
           </a:p>
           <a:p>
             <a:pPr lvl="2"/>
             <a:r>
-              <a:rPr lang="en-US" smtClean="0"/>
+              <a:rPr lang="en-US"/>
               <a:t>Third level</a:t>
             </a:r>
           </a:p>
           <a:p>
             <a:pPr lvl="3"/>
             <a:r>
-              <a:rPr lang="en-US" smtClean="0"/>
+              <a:rPr lang="en-US"/>
               <a:t>Fourth level</a:t>
             </a:r>
           </a:p>
           <a:p>
             <a:pPr lvl="4"/>
             <a:r>
-              <a:rPr lang="en-US" smtClean="0"/>
+              <a:rPr lang="en-US"/>
               <a:t>Fifth level</a:t>
             </a:r>
-            <a:endParaRPr lang="en-US"/>
           </a:p>
         </p:txBody>
       </p:sp>
@@ -2729,7 +2724,7 @@
           <a:p>
             <a:fld id="{5BCAD085-E8A6-8845-BD4E-CB4CCA059FC4}" type="datetimeFigureOut">
               <a:rPr lang="en-US" smtClean="0"/>
-              <a:t>1/27/13</a:t>
+              <a:t>10/29/2026</a:t>
             </a:fld>
             <a:endParaRPr lang="en-US"/>
           </a:p>
@@ -3088,7 +3083,7 @@
 </file>
 
 <file path=ppt/slides/slide1.xml><?xml version="1.0" encoding="utf-8"?>
-<p:sld xmlns:a="http://schemas.openxmlformats.org/drawingml/2006/main" xmlns:p="http://schemas.openxmlformats.org/presentationml/2006/main" xmlns:r="http://schemas.openxmlformats.org/officeDocument/2006/relationships">
+<p:sld xmlns:a="http://schemas.openxmlformats.org/drawingml/2006/main" xmlns:r="http://schemas.openxmlformats.org/officeDocument/2006/relationships" xmlns:p="http://schemas.openxmlformats.org/presentationml/2006/main">
   <p:cSld>
     <p:bg>
       <p:bgPr>
@@ -3104,7 +3099,14 @@
         <p:cNvGrpSpPr/>
         <p:nvPr/>
       </p:nvGrpSpPr>
-      <p:grpSpPr/>
+      <p:grpSpPr>
+        <a:xfrm>
+          <a:off x="0" y="0"/>
+          <a:ext cx="0" cy="0"/>
+          <a:chOff x="0" y="0"/>
+          <a:chExt cx="0" cy="0"/>
+        </a:xfrm>
+      </p:grpSpPr>
       <p:sp>
         <p:nvSpPr>
           <p:cNvPr id="2" name="Rounded Rectangle 1"/>
@@ -3145,6 +3147,7 @@
           <a:lstStyle/>
           <a:p>
             <a:pPr algn="ctr"/>
+            <a:endParaRPr/>
           </a:p>
         </p:txBody>
       </p:sp>
@@ -3188,6 +3191,7 @@
           <a:lstStyle/>
           <a:p>
             <a:pPr algn="ctr"/>
+            <a:endParaRPr/>
           </a:p>
         </p:txBody>
       </p:sp>
@@ -3303,42 +3307,7 @@
           <a:lstStyle/>
           <a:p>
             <a:pPr algn="ctr"/>
-          </a:p>
-        </p:txBody>
-      </p:sp>
-      <p:sp>
-        <p:nvSpPr>
-          <p:cNvPr id="7" name="TextBox 6"/>
-          <p:cNvSpPr txBox="1"/>
-          <p:nvPr/>
-        </p:nvSpPr>
-        <p:spPr>
-          <a:xfrm>
-            <a:off x="493776" y="6419088"/>
-            <a:ext cx="10058400" cy="256032"/>
-          </a:xfrm>
-          <a:prstGeom prst="rect">
-            <a:avLst/>
-          </a:prstGeom>
-          <a:noFill/>
-        </p:spPr>
-        <p:txBody>
-          <a:bodyPr wrap="square">
-            <a:spAutoFit/>
-          </a:bodyPr>
-          <a:lstStyle/>
-          <a:p>
-            <a:pPr>
-              <a:defRPr sz="1000" b="0">
-                <a:solidFill>
-                  <a:srgbClr val="5E6E7F"/>
-                </a:solidFill>
-                <a:latin typeface="Aptos"/>
-              </a:defRPr>
-            </a:pPr>
-            <a:r>
-              <a:t>SMART FILE &amp; MEDIA MANAGER  •  PYTHON + PyQt6</a:t>
-            </a:r>
+            <a:endParaRPr/>
           </a:p>
         </p:txBody>
       </p:sp>
@@ -3454,6 +3423,7 @@
           <a:lstStyle/>
           <a:p>
             <a:pPr algn="ctr"/>
+            <a:endParaRPr/>
           </a:p>
         </p:txBody>
       </p:sp>
@@ -3569,6 +3539,7 @@
           <a:lstStyle/>
           <a:p>
             <a:pPr algn="ctr"/>
+            <a:endParaRPr/>
           </a:p>
         </p:txBody>
       </p:sp>
@@ -3684,6 +3655,7 @@
           <a:lstStyle/>
           <a:p>
             <a:pPr algn="ctr"/>
+            <a:endParaRPr/>
           </a:p>
         </p:txBody>
       </p:sp>
@@ -3768,7 +3740,7 @@
 </file>
 
 <file path=ppt/slides/slide10.xml><?xml version="1.0" encoding="utf-8"?>
-<p:sld xmlns:a="http://schemas.openxmlformats.org/drawingml/2006/main" xmlns:p="http://schemas.openxmlformats.org/presentationml/2006/main" xmlns:r="http://schemas.openxmlformats.org/officeDocument/2006/relationships">
+<p:sld xmlns:a="http://schemas.openxmlformats.org/drawingml/2006/main" xmlns:r="http://schemas.openxmlformats.org/officeDocument/2006/relationships" xmlns:p="http://schemas.openxmlformats.org/presentationml/2006/main">
   <p:cSld>
     <p:bg>
       <p:bgPr>
@@ -3784,7 +3756,14 @@
         <p:cNvGrpSpPr/>
         <p:nvPr/>
       </p:nvGrpSpPr>
-      <p:grpSpPr/>
+      <p:grpSpPr>
+        <a:xfrm>
+          <a:off x="0" y="0"/>
+          <a:ext cx="0" cy="0"/>
+          <a:chOff x="0" y="0"/>
+          <a:chExt cx="0" cy="0"/>
+        </a:xfrm>
+      </p:grpSpPr>
       <p:sp>
         <p:nvSpPr>
           <p:cNvPr id="2" name="Rounded Rectangle 1"/>
@@ -3825,6 +3804,7 @@
           <a:lstStyle/>
           <a:p>
             <a:pPr algn="ctr"/>
+            <a:endParaRPr/>
           </a:p>
         </p:txBody>
       </p:sp>
@@ -3868,6 +3848,7 @@
           <a:lstStyle/>
           <a:p>
             <a:pPr algn="ctr"/>
+            <a:endParaRPr/>
           </a:p>
         </p:txBody>
       </p:sp>
@@ -3983,42 +3964,7 @@
           <a:lstStyle/>
           <a:p>
             <a:pPr algn="ctr"/>
-          </a:p>
-        </p:txBody>
-      </p:sp>
-      <p:sp>
-        <p:nvSpPr>
-          <p:cNvPr id="7" name="TextBox 6"/>
-          <p:cNvSpPr txBox="1"/>
-          <p:nvPr/>
-        </p:nvSpPr>
-        <p:spPr>
-          <a:xfrm>
-            <a:off x="493776" y="6419088"/>
-            <a:ext cx="10058400" cy="256032"/>
-          </a:xfrm>
-          <a:prstGeom prst="rect">
-            <a:avLst/>
-          </a:prstGeom>
-          <a:noFill/>
-        </p:spPr>
-        <p:txBody>
-          <a:bodyPr wrap="square">
-            <a:spAutoFit/>
-          </a:bodyPr>
-          <a:lstStyle/>
-          <a:p>
-            <a:pPr>
-              <a:defRPr sz="1000" b="0">
-                <a:solidFill>
-                  <a:srgbClr val="5E6E7F"/>
-                </a:solidFill>
-                <a:latin typeface="Aptos"/>
-              </a:defRPr>
-            </a:pPr>
-            <a:r>
-              <a:t>SMART FILE &amp; MEDIA MANAGER  •  PYTHON + PyQt6</a:t>
-            </a:r>
+            <a:endParaRPr/>
           </a:p>
         </p:txBody>
       </p:sp>
@@ -4098,6 +4044,7 @@
           <a:lstStyle/>
           <a:p>
             <a:pPr algn="ctr"/>
+            <a:endParaRPr/>
           </a:p>
         </p:txBody>
       </p:sp>
@@ -4177,6 +4124,7 @@
           <a:lstStyle/>
           <a:p>
             <a:pPr algn="ctr"/>
+            <a:endParaRPr/>
           </a:p>
         </p:txBody>
       </p:sp>
@@ -4256,6 +4204,7 @@
           <a:lstStyle/>
           <a:p>
             <a:pPr algn="ctr"/>
+            <a:endParaRPr/>
           </a:p>
         </p:txBody>
       </p:sp>
@@ -4335,6 +4284,7 @@
           <a:lstStyle/>
           <a:p>
             <a:pPr algn="ctr"/>
+            <a:endParaRPr/>
           </a:p>
         </p:txBody>
       </p:sp>
@@ -4414,6 +4364,7 @@
           <a:lstStyle/>
           <a:p>
             <a:pPr algn="ctr"/>
+            <a:endParaRPr/>
           </a:p>
         </p:txBody>
       </p:sp>
@@ -4462,7 +4413,7 @@
 </file>
 
 <file path=ppt/slides/slide2.xml><?xml version="1.0" encoding="utf-8"?>
-<p:sld xmlns:a="http://schemas.openxmlformats.org/drawingml/2006/main" xmlns:p="http://schemas.openxmlformats.org/presentationml/2006/main" xmlns:r="http://schemas.openxmlformats.org/officeDocument/2006/relationships">
+<p:sld xmlns:a="http://schemas.openxmlformats.org/drawingml/2006/main" xmlns:r="http://schemas.openxmlformats.org/officeDocument/2006/relationships" xmlns:p="http://schemas.openxmlformats.org/presentationml/2006/main">
   <p:cSld>
     <p:bg>
       <p:bgPr>
@@ -4478,7 +4429,14 @@
         <p:cNvGrpSpPr/>
         <p:nvPr/>
       </p:nvGrpSpPr>
-      <p:grpSpPr/>
+      <p:grpSpPr>
+        <a:xfrm>
+          <a:off x="0" y="0"/>
+          <a:ext cx="0" cy="0"/>
+          <a:chOff x="0" y="0"/>
+          <a:chExt cx="0" cy="0"/>
+        </a:xfrm>
+      </p:grpSpPr>
       <p:sp>
         <p:nvSpPr>
           <p:cNvPr id="2" name="Rounded Rectangle 1"/>
@@ -4519,6 +4477,7 @@
           <a:lstStyle/>
           <a:p>
             <a:pPr algn="ctr"/>
+            <a:endParaRPr/>
           </a:p>
         </p:txBody>
       </p:sp>
@@ -4562,6 +4521,7 @@
           <a:lstStyle/>
           <a:p>
             <a:pPr algn="ctr"/>
+            <a:endParaRPr/>
           </a:p>
         </p:txBody>
       </p:sp>
@@ -4677,42 +4637,7 @@
           <a:lstStyle/>
           <a:p>
             <a:pPr algn="ctr"/>
-          </a:p>
-        </p:txBody>
-      </p:sp>
-      <p:sp>
-        <p:nvSpPr>
-          <p:cNvPr id="7" name="TextBox 6"/>
-          <p:cNvSpPr txBox="1"/>
-          <p:nvPr/>
-        </p:nvSpPr>
-        <p:spPr>
-          <a:xfrm>
-            <a:off x="493776" y="6419088"/>
-            <a:ext cx="10058400" cy="256032"/>
-          </a:xfrm>
-          <a:prstGeom prst="rect">
-            <a:avLst/>
-          </a:prstGeom>
-          <a:noFill/>
-        </p:spPr>
-        <p:txBody>
-          <a:bodyPr wrap="square">
-            <a:spAutoFit/>
-          </a:bodyPr>
-          <a:lstStyle/>
-          <a:p>
-            <a:pPr>
-              <a:defRPr sz="1000" b="0">
-                <a:solidFill>
-                  <a:srgbClr val="5E6E7F"/>
-                </a:solidFill>
-                <a:latin typeface="Aptos"/>
-              </a:defRPr>
-            </a:pPr>
-            <a:r>
-              <a:t>SMART FILE &amp; MEDIA MANAGER  •  PYTHON + PyQt6</a:t>
-            </a:r>
+            <a:endParaRPr/>
           </a:p>
         </p:txBody>
       </p:sp>
@@ -4792,6 +4717,7 @@
           <a:lstStyle/>
           <a:p>
             <a:pPr algn="ctr"/>
+            <a:endParaRPr/>
           </a:p>
         </p:txBody>
       </p:sp>
@@ -4871,6 +4797,7 @@
           <a:lstStyle/>
           <a:p>
             <a:pPr algn="ctr"/>
+            <a:endParaRPr/>
           </a:p>
         </p:txBody>
       </p:sp>
@@ -4950,6 +4877,7 @@
           <a:lstStyle/>
           <a:p>
             <a:pPr algn="ctr"/>
+            <a:endParaRPr/>
           </a:p>
         </p:txBody>
       </p:sp>
@@ -5029,6 +4957,7 @@
           <a:lstStyle/>
           <a:p>
             <a:pPr algn="ctr"/>
+            <a:endParaRPr/>
           </a:p>
         </p:txBody>
       </p:sp>
@@ -5108,6 +5037,7 @@
           <a:lstStyle/>
           <a:p>
             <a:pPr algn="ctr"/>
+            <a:endParaRPr/>
           </a:p>
         </p:txBody>
       </p:sp>
@@ -5156,7 +5086,7 @@
 </file>
 
 <file path=ppt/slides/slide3.xml><?xml version="1.0" encoding="utf-8"?>
-<p:sld xmlns:a="http://schemas.openxmlformats.org/drawingml/2006/main" xmlns:p="http://schemas.openxmlformats.org/presentationml/2006/main" xmlns:r="http://schemas.openxmlformats.org/officeDocument/2006/relationships">
+<p:sld xmlns:a="http://schemas.openxmlformats.org/drawingml/2006/main" xmlns:r="http://schemas.openxmlformats.org/officeDocument/2006/relationships" xmlns:p="http://schemas.openxmlformats.org/presentationml/2006/main">
   <p:cSld>
     <p:bg>
       <p:bgPr>
@@ -5172,7 +5102,14 @@
         <p:cNvGrpSpPr/>
         <p:nvPr/>
       </p:nvGrpSpPr>
-      <p:grpSpPr/>
+      <p:grpSpPr>
+        <a:xfrm>
+          <a:off x="0" y="0"/>
+          <a:ext cx="0" cy="0"/>
+          <a:chOff x="0" y="0"/>
+          <a:chExt cx="0" cy="0"/>
+        </a:xfrm>
+      </p:grpSpPr>
       <p:sp>
         <p:nvSpPr>
           <p:cNvPr id="2" name="Rounded Rectangle 1"/>
@@ -5213,6 +5150,7 @@
           <a:lstStyle/>
           <a:p>
             <a:pPr algn="ctr"/>
+            <a:endParaRPr/>
           </a:p>
         </p:txBody>
       </p:sp>
@@ -5256,6 +5194,7 @@
           <a:lstStyle/>
           <a:p>
             <a:pPr algn="ctr"/>
+            <a:endParaRPr/>
           </a:p>
         </p:txBody>
       </p:sp>
@@ -5371,42 +5310,7 @@
           <a:lstStyle/>
           <a:p>
             <a:pPr algn="ctr"/>
-          </a:p>
-        </p:txBody>
-      </p:sp>
-      <p:sp>
-        <p:nvSpPr>
-          <p:cNvPr id="7" name="TextBox 6"/>
-          <p:cNvSpPr txBox="1"/>
-          <p:nvPr/>
-        </p:nvSpPr>
-        <p:spPr>
-          <a:xfrm>
-            <a:off x="493776" y="6419088"/>
-            <a:ext cx="10058400" cy="256032"/>
-          </a:xfrm>
-          <a:prstGeom prst="rect">
-            <a:avLst/>
-          </a:prstGeom>
-          <a:noFill/>
-        </p:spPr>
-        <p:txBody>
-          <a:bodyPr wrap="square">
-            <a:spAutoFit/>
-          </a:bodyPr>
-          <a:lstStyle/>
-          <a:p>
-            <a:pPr>
-              <a:defRPr sz="1000" b="0">
-                <a:solidFill>
-                  <a:srgbClr val="5E6E7F"/>
-                </a:solidFill>
-                <a:latin typeface="Aptos"/>
-              </a:defRPr>
-            </a:pPr>
-            <a:r>
-              <a:t>SMART FILE &amp; MEDIA MANAGER  •  PYTHON + PyQt6</a:t>
-            </a:r>
+            <a:endParaRPr/>
           </a:p>
         </p:txBody>
       </p:sp>
@@ -5486,6 +5390,7 @@
           <a:lstStyle/>
           <a:p>
             <a:pPr algn="ctr"/>
+            <a:endParaRPr/>
           </a:p>
         </p:txBody>
       </p:sp>
@@ -5529,6 +5434,7 @@
           <a:lstStyle/>
           <a:p>
             <a:pPr algn="ctr"/>
+            <a:endParaRPr/>
           </a:p>
         </p:txBody>
       </p:sp>
@@ -5680,6 +5586,7 @@
           <a:lstStyle/>
           <a:p>
             <a:pPr algn="ctr"/>
+            <a:endParaRPr/>
           </a:p>
         </p:txBody>
       </p:sp>
@@ -5723,6 +5630,7 @@
           <a:lstStyle/>
           <a:p>
             <a:pPr algn="ctr"/>
+            <a:endParaRPr/>
           </a:p>
         </p:txBody>
       </p:sp>
@@ -5895,7 +5803,7 @@
 </file>
 
 <file path=ppt/slides/slide4.xml><?xml version="1.0" encoding="utf-8"?>
-<p:sld xmlns:a="http://schemas.openxmlformats.org/drawingml/2006/main" xmlns:p="http://schemas.openxmlformats.org/presentationml/2006/main" xmlns:r="http://schemas.openxmlformats.org/officeDocument/2006/relationships">
+<p:sld xmlns:a="http://schemas.openxmlformats.org/drawingml/2006/main" xmlns:r="http://schemas.openxmlformats.org/officeDocument/2006/relationships" xmlns:p="http://schemas.openxmlformats.org/presentationml/2006/main">
   <p:cSld>
     <p:bg>
       <p:bgPr>
@@ -5911,7 +5819,14 @@
         <p:cNvGrpSpPr/>
         <p:nvPr/>
       </p:nvGrpSpPr>
-      <p:grpSpPr/>
+      <p:grpSpPr>
+        <a:xfrm>
+          <a:off x="0" y="0"/>
+          <a:ext cx="0" cy="0"/>
+          <a:chOff x="0" y="0"/>
+          <a:chExt cx="0" cy="0"/>
+        </a:xfrm>
+      </p:grpSpPr>
       <p:sp>
         <p:nvSpPr>
           <p:cNvPr id="2" name="Rounded Rectangle 1"/>
@@ -5952,6 +5867,7 @@
           <a:lstStyle/>
           <a:p>
             <a:pPr algn="ctr"/>
+            <a:endParaRPr/>
           </a:p>
         </p:txBody>
       </p:sp>
@@ -5995,6 +5911,7 @@
           <a:lstStyle/>
           <a:p>
             <a:pPr algn="ctr"/>
+            <a:endParaRPr/>
           </a:p>
         </p:txBody>
       </p:sp>
@@ -6110,42 +6027,7 @@
           <a:lstStyle/>
           <a:p>
             <a:pPr algn="ctr"/>
-          </a:p>
-        </p:txBody>
-      </p:sp>
-      <p:sp>
-        <p:nvSpPr>
-          <p:cNvPr id="7" name="TextBox 6"/>
-          <p:cNvSpPr txBox="1"/>
-          <p:nvPr/>
-        </p:nvSpPr>
-        <p:spPr>
-          <a:xfrm>
-            <a:off x="493776" y="6419088"/>
-            <a:ext cx="10058400" cy="256032"/>
-          </a:xfrm>
-          <a:prstGeom prst="rect">
-            <a:avLst/>
-          </a:prstGeom>
-          <a:noFill/>
-        </p:spPr>
-        <p:txBody>
-          <a:bodyPr wrap="square">
-            <a:spAutoFit/>
-          </a:bodyPr>
-          <a:lstStyle/>
-          <a:p>
-            <a:pPr>
-              <a:defRPr sz="1000" b="0">
-                <a:solidFill>
-                  <a:srgbClr val="5E6E7F"/>
-                </a:solidFill>
-                <a:latin typeface="Aptos"/>
-              </a:defRPr>
-            </a:pPr>
-            <a:r>
-              <a:t>SMART FILE &amp; MEDIA MANAGER  •  PYTHON + PyQt6</a:t>
-            </a:r>
+            <a:endParaRPr/>
           </a:p>
         </p:txBody>
       </p:sp>
@@ -6225,6 +6107,7 @@
           <a:lstStyle/>
           <a:p>
             <a:pPr algn="ctr"/>
+            <a:endParaRPr/>
           </a:p>
         </p:txBody>
       </p:sp>
@@ -6376,6 +6259,7 @@
           <a:lstStyle/>
           <a:p>
             <a:pPr algn="ctr"/>
+            <a:endParaRPr/>
           </a:p>
         </p:txBody>
       </p:sp>
@@ -6527,6 +6411,7 @@
           <a:lstStyle/>
           <a:p>
             <a:pPr algn="ctr"/>
+            <a:endParaRPr/>
           </a:p>
         </p:txBody>
       </p:sp>
@@ -6683,7 +6568,7 @@
 </file>
 
 <file path=ppt/slides/slide5.xml><?xml version="1.0" encoding="utf-8"?>
-<p:sld xmlns:a="http://schemas.openxmlformats.org/drawingml/2006/main" xmlns:p="http://schemas.openxmlformats.org/presentationml/2006/main" xmlns:r="http://schemas.openxmlformats.org/officeDocument/2006/relationships">
+<p:sld xmlns:a="http://schemas.openxmlformats.org/drawingml/2006/main" xmlns:r="http://schemas.openxmlformats.org/officeDocument/2006/relationships" xmlns:p="http://schemas.openxmlformats.org/presentationml/2006/main">
   <p:cSld>
     <p:bg>
       <p:bgPr>
@@ -6699,7 +6584,14 @@
         <p:cNvGrpSpPr/>
         <p:nvPr/>
       </p:nvGrpSpPr>
-      <p:grpSpPr/>
+      <p:grpSpPr>
+        <a:xfrm>
+          <a:off x="0" y="0"/>
+          <a:ext cx="0" cy="0"/>
+          <a:chOff x="0" y="0"/>
+          <a:chExt cx="0" cy="0"/>
+        </a:xfrm>
+      </p:grpSpPr>
       <p:sp>
         <p:nvSpPr>
           <p:cNvPr id="2" name="Rounded Rectangle 1"/>
@@ -6740,6 +6632,7 @@
           <a:lstStyle/>
           <a:p>
             <a:pPr algn="ctr"/>
+            <a:endParaRPr/>
           </a:p>
         </p:txBody>
       </p:sp>
@@ -6783,6 +6676,7 @@
           <a:lstStyle/>
           <a:p>
             <a:pPr algn="ctr"/>
+            <a:endParaRPr/>
           </a:p>
         </p:txBody>
       </p:sp>
@@ -6898,42 +6792,7 @@
           <a:lstStyle/>
           <a:p>
             <a:pPr algn="ctr"/>
-          </a:p>
-        </p:txBody>
-      </p:sp>
-      <p:sp>
-        <p:nvSpPr>
-          <p:cNvPr id="7" name="TextBox 6"/>
-          <p:cNvSpPr txBox="1"/>
-          <p:nvPr/>
-        </p:nvSpPr>
-        <p:spPr>
-          <a:xfrm>
-            <a:off x="493776" y="6419088"/>
-            <a:ext cx="10058400" cy="256032"/>
-          </a:xfrm>
-          <a:prstGeom prst="rect">
-            <a:avLst/>
-          </a:prstGeom>
-          <a:noFill/>
-        </p:spPr>
-        <p:txBody>
-          <a:bodyPr wrap="square">
-            <a:spAutoFit/>
-          </a:bodyPr>
-          <a:lstStyle/>
-          <a:p>
-            <a:pPr>
-              <a:defRPr sz="1000" b="0">
-                <a:solidFill>
-                  <a:srgbClr val="5E6E7F"/>
-                </a:solidFill>
-                <a:latin typeface="Aptos"/>
-              </a:defRPr>
-            </a:pPr>
-            <a:r>
-              <a:t>SMART FILE &amp; MEDIA MANAGER  •  PYTHON + PyQt6</a:t>
-            </a:r>
+            <a:endParaRPr/>
           </a:p>
         </p:txBody>
       </p:sp>
@@ -7013,6 +6872,7 @@
           <a:lstStyle/>
           <a:p>
             <a:pPr algn="ctr"/>
+            <a:endParaRPr/>
           </a:p>
         </p:txBody>
       </p:sp>
@@ -7092,6 +6952,7 @@
           <a:lstStyle/>
           <a:p>
             <a:pPr algn="ctr"/>
+            <a:endParaRPr/>
           </a:p>
         </p:txBody>
       </p:sp>
@@ -7171,6 +7032,7 @@
           <a:lstStyle/>
           <a:p>
             <a:pPr algn="ctr"/>
+            <a:endParaRPr/>
           </a:p>
         </p:txBody>
       </p:sp>
@@ -7250,6 +7112,7 @@
           <a:lstStyle/>
           <a:p>
             <a:pPr algn="ctr"/>
+            <a:endParaRPr/>
           </a:p>
         </p:txBody>
       </p:sp>
@@ -7329,6 +7192,7 @@
           <a:lstStyle/>
           <a:p>
             <a:pPr algn="ctr"/>
+            <a:endParaRPr/>
           </a:p>
         </p:txBody>
       </p:sp>
@@ -7377,7 +7241,7 @@
 </file>
 
 <file path=ppt/slides/slide6.xml><?xml version="1.0" encoding="utf-8"?>
-<p:sld xmlns:a="http://schemas.openxmlformats.org/drawingml/2006/main" xmlns:p="http://schemas.openxmlformats.org/presentationml/2006/main" xmlns:r="http://schemas.openxmlformats.org/officeDocument/2006/relationships">
+<p:sld xmlns:a="http://schemas.openxmlformats.org/drawingml/2006/main" xmlns:r="http://schemas.openxmlformats.org/officeDocument/2006/relationships" xmlns:p="http://schemas.openxmlformats.org/presentationml/2006/main">
   <p:cSld>
     <p:bg>
       <p:bgPr>
@@ -7393,7 +7257,14 @@
         <p:cNvGrpSpPr/>
         <p:nvPr/>
       </p:nvGrpSpPr>
-      <p:grpSpPr/>
+      <p:grpSpPr>
+        <a:xfrm>
+          <a:off x="0" y="0"/>
+          <a:ext cx="0" cy="0"/>
+          <a:chOff x="0" y="0"/>
+          <a:chExt cx="0" cy="0"/>
+        </a:xfrm>
+      </p:grpSpPr>
       <p:sp>
         <p:nvSpPr>
           <p:cNvPr id="2" name="Rounded Rectangle 1"/>
@@ -7434,6 +7305,7 @@
           <a:lstStyle/>
           <a:p>
             <a:pPr algn="ctr"/>
+            <a:endParaRPr/>
           </a:p>
         </p:txBody>
       </p:sp>
@@ -7477,6 +7349,7 @@
           <a:lstStyle/>
           <a:p>
             <a:pPr algn="ctr"/>
+            <a:endParaRPr/>
           </a:p>
         </p:txBody>
       </p:sp>
@@ -7592,42 +7465,7 @@
           <a:lstStyle/>
           <a:p>
             <a:pPr algn="ctr"/>
-          </a:p>
-        </p:txBody>
-      </p:sp>
-      <p:sp>
-        <p:nvSpPr>
-          <p:cNvPr id="7" name="TextBox 6"/>
-          <p:cNvSpPr txBox="1"/>
-          <p:nvPr/>
-        </p:nvSpPr>
-        <p:spPr>
-          <a:xfrm>
-            <a:off x="493776" y="6419088"/>
-            <a:ext cx="10058400" cy="256032"/>
-          </a:xfrm>
-          <a:prstGeom prst="rect">
-            <a:avLst/>
-          </a:prstGeom>
-          <a:noFill/>
-        </p:spPr>
-        <p:txBody>
-          <a:bodyPr wrap="square">
-            <a:spAutoFit/>
-          </a:bodyPr>
-          <a:lstStyle/>
-          <a:p>
-            <a:pPr>
-              <a:defRPr sz="1000" b="0">
-                <a:solidFill>
-                  <a:srgbClr val="5E6E7F"/>
-                </a:solidFill>
-                <a:latin typeface="Aptos"/>
-              </a:defRPr>
-            </a:pPr>
-            <a:r>
-              <a:t>SMART FILE &amp; MEDIA MANAGER  •  PYTHON + PyQt6</a:t>
-            </a:r>
+            <a:endParaRPr/>
           </a:p>
         </p:txBody>
       </p:sp>
@@ -7707,6 +7545,7 @@
           <a:lstStyle/>
           <a:p>
             <a:pPr algn="ctr"/>
+            <a:endParaRPr/>
           </a:p>
         </p:txBody>
       </p:sp>
@@ -7786,6 +7625,7 @@
           <a:lstStyle/>
           <a:p>
             <a:pPr algn="ctr"/>
+            <a:endParaRPr/>
           </a:p>
         </p:txBody>
       </p:sp>
@@ -7865,6 +7705,7 @@
           <a:lstStyle/>
           <a:p>
             <a:pPr algn="ctr"/>
+            <a:endParaRPr/>
           </a:p>
         </p:txBody>
       </p:sp>
@@ -7944,6 +7785,7 @@
           <a:lstStyle/>
           <a:p>
             <a:pPr algn="ctr"/>
+            <a:endParaRPr/>
           </a:p>
         </p:txBody>
       </p:sp>
@@ -8023,6 +7865,7 @@
           <a:lstStyle/>
           <a:p>
             <a:pPr algn="ctr"/>
+            <a:endParaRPr/>
           </a:p>
         </p:txBody>
       </p:sp>
@@ -8071,7 +7914,7 @@
 </file>
 
 <file path=ppt/slides/slide7.xml><?xml version="1.0" encoding="utf-8"?>
-<p:sld xmlns:a="http://schemas.openxmlformats.org/drawingml/2006/main" xmlns:p="http://schemas.openxmlformats.org/presentationml/2006/main" xmlns:r="http://schemas.openxmlformats.org/officeDocument/2006/relationships">
+<p:sld xmlns:a="http://schemas.openxmlformats.org/drawingml/2006/main" xmlns:r="http://schemas.openxmlformats.org/officeDocument/2006/relationships" xmlns:p="http://schemas.openxmlformats.org/presentationml/2006/main">
   <p:cSld>
     <p:bg>
       <p:bgPr>
@@ -8087,7 +7930,14 @@
         <p:cNvGrpSpPr/>
         <p:nvPr/>
       </p:nvGrpSpPr>
-      <p:grpSpPr/>
+      <p:grpSpPr>
+        <a:xfrm>
+          <a:off x="0" y="0"/>
+          <a:ext cx="0" cy="0"/>
+          <a:chOff x="0" y="0"/>
+          <a:chExt cx="0" cy="0"/>
+        </a:xfrm>
+      </p:grpSpPr>
       <p:sp>
         <p:nvSpPr>
           <p:cNvPr id="2" name="Rounded Rectangle 1"/>
@@ -8128,6 +7978,7 @@
           <a:lstStyle/>
           <a:p>
             <a:pPr algn="ctr"/>
+            <a:endParaRPr/>
           </a:p>
         </p:txBody>
       </p:sp>
@@ -8171,6 +8022,7 @@
           <a:lstStyle/>
           <a:p>
             <a:pPr algn="ctr"/>
+            <a:endParaRPr/>
           </a:p>
         </p:txBody>
       </p:sp>
@@ -8286,42 +8138,7 @@
           <a:lstStyle/>
           <a:p>
             <a:pPr algn="ctr"/>
-          </a:p>
-        </p:txBody>
-      </p:sp>
-      <p:sp>
-        <p:nvSpPr>
-          <p:cNvPr id="7" name="TextBox 6"/>
-          <p:cNvSpPr txBox="1"/>
-          <p:nvPr/>
-        </p:nvSpPr>
-        <p:spPr>
-          <a:xfrm>
-            <a:off x="493776" y="6419088"/>
-            <a:ext cx="10058400" cy="256032"/>
-          </a:xfrm>
-          <a:prstGeom prst="rect">
-            <a:avLst/>
-          </a:prstGeom>
-          <a:noFill/>
-        </p:spPr>
-        <p:txBody>
-          <a:bodyPr wrap="square">
-            <a:spAutoFit/>
-          </a:bodyPr>
-          <a:lstStyle/>
-          <a:p>
-            <a:pPr>
-              <a:defRPr sz="1000" b="0">
-                <a:solidFill>
-                  <a:srgbClr val="5E6E7F"/>
-                </a:solidFill>
-                <a:latin typeface="Aptos"/>
-              </a:defRPr>
-            </a:pPr>
-            <a:r>
-              <a:t>SMART FILE &amp; MEDIA MANAGER  •  PYTHON + PyQt6</a:t>
-            </a:r>
+            <a:endParaRPr/>
           </a:p>
         </p:txBody>
       </p:sp>
@@ -8437,6 +8254,7 @@
           <a:lstStyle/>
           <a:p>
             <a:pPr algn="ctr"/>
+            <a:endParaRPr/>
           </a:p>
         </p:txBody>
       </p:sp>
@@ -8552,6 +8370,7 @@
           <a:lstStyle/>
           <a:p>
             <a:pPr algn="ctr"/>
+            <a:endParaRPr/>
           </a:p>
         </p:txBody>
       </p:sp>
@@ -8708,7 +8527,7 @@
 </file>
 
 <file path=ppt/slides/slide8.xml><?xml version="1.0" encoding="utf-8"?>
-<p:sld xmlns:a="http://schemas.openxmlformats.org/drawingml/2006/main" xmlns:p="http://schemas.openxmlformats.org/presentationml/2006/main" xmlns:r="http://schemas.openxmlformats.org/officeDocument/2006/relationships">
+<p:sld xmlns:a="http://schemas.openxmlformats.org/drawingml/2006/main" xmlns:r="http://schemas.openxmlformats.org/officeDocument/2006/relationships" xmlns:p="http://schemas.openxmlformats.org/presentationml/2006/main">
   <p:cSld>
     <p:bg>
       <p:bgPr>
@@ -8724,7 +8543,14 @@
         <p:cNvGrpSpPr/>
         <p:nvPr/>
       </p:nvGrpSpPr>
-      <p:grpSpPr/>
+      <p:grpSpPr>
+        <a:xfrm>
+          <a:off x="0" y="0"/>
+          <a:ext cx="0" cy="0"/>
+          <a:chOff x="0" y="0"/>
+          <a:chExt cx="0" cy="0"/>
+        </a:xfrm>
+      </p:grpSpPr>
       <p:sp>
         <p:nvSpPr>
           <p:cNvPr id="2" name="Rounded Rectangle 1"/>
@@ -8765,6 +8591,7 @@
           <a:lstStyle/>
           <a:p>
             <a:pPr algn="ctr"/>
+            <a:endParaRPr/>
           </a:p>
         </p:txBody>
       </p:sp>
@@ -8808,6 +8635,7 @@
           <a:lstStyle/>
           <a:p>
             <a:pPr algn="ctr"/>
+            <a:endParaRPr/>
           </a:p>
         </p:txBody>
       </p:sp>
@@ -8923,6 +8751,7 @@
           <a:lstStyle/>
           <a:p>
             <a:pPr algn="ctr"/>
+            <a:endParaRPr/>
           </a:p>
         </p:txBody>
       </p:sp>
@@ -9038,6 +8867,7 @@
           <a:lstStyle/>
           <a:p>
             <a:pPr algn="ctr"/>
+            <a:endParaRPr/>
           </a:p>
         </p:txBody>
       </p:sp>
@@ -9117,6 +8947,7 @@
           <a:lstStyle/>
           <a:p>
             <a:pPr algn="ctr"/>
+            <a:endParaRPr/>
           </a:p>
         </p:txBody>
       </p:sp>
@@ -9196,6 +9027,7 @@
           <a:lstStyle/>
           <a:p>
             <a:pPr algn="ctr"/>
+            <a:endParaRPr/>
           </a:p>
         </p:txBody>
       </p:sp>
@@ -9275,6 +9107,7 @@
           <a:lstStyle/>
           <a:p>
             <a:pPr algn="ctr"/>
+            <a:endParaRPr/>
           </a:p>
         </p:txBody>
       </p:sp>
@@ -9354,6 +9187,7 @@
           <a:lstStyle/>
           <a:p>
             <a:pPr algn="ctr"/>
+            <a:endParaRPr/>
           </a:p>
         </p:txBody>
       </p:sp>
@@ -9402,7 +9236,7 @@
 </file>
 
 <file path=ppt/slides/slide9.xml><?xml version="1.0" encoding="utf-8"?>
-<p:sld xmlns:a="http://schemas.openxmlformats.org/drawingml/2006/main" xmlns:p="http://schemas.openxmlformats.org/presentationml/2006/main" xmlns:r="http://schemas.openxmlformats.org/officeDocument/2006/relationships">
+<p:sld xmlns:a="http://schemas.openxmlformats.org/drawingml/2006/main" xmlns:r="http://schemas.openxmlformats.org/officeDocument/2006/relationships" xmlns:p="http://schemas.openxmlformats.org/presentationml/2006/main">
   <p:cSld>
     <p:bg>
       <p:bgPr>
@@ -9418,7 +9252,14 @@
         <p:cNvGrpSpPr/>
         <p:nvPr/>
       </p:nvGrpSpPr>
-      <p:grpSpPr/>
+      <p:grpSpPr>
+        <a:xfrm>
+          <a:off x="0" y="0"/>
+          <a:ext cx="0" cy="0"/>
+          <a:chOff x="0" y="0"/>
+          <a:chExt cx="0" cy="0"/>
+        </a:xfrm>
+      </p:grpSpPr>
       <p:sp>
         <p:nvSpPr>
           <p:cNvPr id="2" name="Rounded Rectangle 1"/>
@@ -9459,6 +9300,7 @@
           <a:lstStyle/>
           <a:p>
             <a:pPr algn="ctr"/>
+            <a:endParaRPr/>
           </a:p>
         </p:txBody>
       </p:sp>
@@ -9502,6 +9344,7 @@
           <a:lstStyle/>
           <a:p>
             <a:pPr algn="ctr"/>
+            <a:endParaRPr/>
           </a:p>
         </p:txBody>
       </p:sp>
@@ -9617,42 +9460,7 @@
           <a:lstStyle/>
           <a:p>
             <a:pPr algn="ctr"/>
-          </a:p>
-        </p:txBody>
-      </p:sp>
-      <p:sp>
-        <p:nvSpPr>
-          <p:cNvPr id="7" name="TextBox 6"/>
-          <p:cNvSpPr txBox="1"/>
-          <p:nvPr/>
-        </p:nvSpPr>
-        <p:spPr>
-          <a:xfrm>
-            <a:off x="493776" y="6419088"/>
-            <a:ext cx="10058400" cy="256032"/>
-          </a:xfrm>
-          <a:prstGeom prst="rect">
-            <a:avLst/>
-          </a:prstGeom>
-          <a:noFill/>
-        </p:spPr>
-        <p:txBody>
-          <a:bodyPr wrap="square">
-            <a:spAutoFit/>
-          </a:bodyPr>
-          <a:lstStyle/>
-          <a:p>
-            <a:pPr>
-              <a:defRPr sz="1000" b="0">
-                <a:solidFill>
-                  <a:srgbClr val="5E6E7F"/>
-                </a:solidFill>
-                <a:latin typeface="Aptos"/>
-              </a:defRPr>
-            </a:pPr>
-            <a:r>
-              <a:t>SMART FILE &amp; MEDIA MANAGER  •  PYTHON + PyQt6</a:t>
-            </a:r>
+            <a:endParaRPr/>
           </a:p>
         </p:txBody>
       </p:sp>
@@ -9732,6 +9540,7 @@
           <a:lstStyle/>
           <a:p>
             <a:pPr algn="ctr"/>
+            <a:endParaRPr/>
           </a:p>
         </p:txBody>
       </p:sp>
@@ -9811,6 +9620,7 @@
           <a:lstStyle/>
           <a:p>
             <a:pPr algn="ctr"/>
+            <a:endParaRPr/>
           </a:p>
         </p:txBody>
       </p:sp>
@@ -9890,6 +9700,7 @@
           <a:lstStyle/>
           <a:p>
             <a:pPr algn="ctr"/>
+            <a:endParaRPr/>
           </a:p>
         </p:txBody>
       </p:sp>
@@ -9969,6 +9780,7 @@
           <a:lstStyle/>
           <a:p>
             <a:pPr algn="ctr"/>
+            <a:endParaRPr/>
           </a:p>
         </p:txBody>
       </p:sp>
@@ -10048,6 +9860,7 @@
           <a:lstStyle/>
           <a:p>
             <a:pPr algn="ctr"/>
+            <a:endParaRPr/>
           </a:p>
         </p:txBody>
       </p:sp>

</xml_diff>